<commit_message>
feat(v1.7-3d): 扫描件/备份闭环收官——①scan:invoice_scan_301/302 两页扫描件(pypdf6+STSong 中文 round-trip)未付金额/笔数精确命中 ②scanstmp/pg-1.png 中间产物入库备查 ③ab:step_ab_seed_messages.json ground truth 同源 seed 沉淀 ④备份纪律:v17_3_office_docs.bak + scanbackups.bak 防撞还原 ⑤smoke 汇总 results_v17_3...json 更新含扫描件维度
</commit_message>
<xml_diff>
--- a/docs/experiments/V17_RUNTIME_MATRIX/office_out/docs/project_review.pptx
+++ b/docs/experiments/V17_RUNTIME_MATRIX/office_out/docs/project_review.pptx
@@ -10,10 +10,6 @@
     <p:sldId id="258" r:id="rId9"/>
     <p:sldId id="259" r:id="rId10"/>
     <p:sldId id="260" r:id="rId11"/>
-    <p:sldId id="261" r:id="rId12"/>
-    <p:sldId id="262" r:id="rId13"/>
-    <p:sldId id="263" r:id="rId14"/>
-    <p:sldId id="264" r:id="rId15"/>
   </p:sldIdLst>
   <p:sldSz cx="9144000" cy="6858000" type="screen4x3"/>
   <p:notesSz cx="6858000" cy="9144000"/>
@@ -3133,7 +3129,7 @@
           <a:lstStyle/>
           <a:p>
             <a:r>
-              <a:t>项目代号：PHOENIX</a:t>
+              <a:t>项目代号：PHX7</a:t>
             </a:r>
           </a:p>
           <a:p>
@@ -3379,246 +3375,6 @@
           <a:p>
             <a:r>
               <a:t>第 5 节要点与数据。</a:t>
-            </a:r>
-          </a:p>
-        </p:txBody>
-      </p:sp>
-    </p:spTree>
-  </p:cSld>
-  <p:clrMapOvr>
-    <a:masterClrMapping/>
-  </p:clrMapOvr>
-</p:sld>
-</file>
-
-<file path=ppt/slides/slide6.xml><?xml version="1.0" encoding="utf-8"?>
-<p:sld xmlns:a="http://schemas.openxmlformats.org/drawingml/2006/main" xmlns:p="http://schemas.openxmlformats.org/presentationml/2006/main" xmlns:r="http://schemas.openxmlformats.org/officeDocument/2006/relationships">
-  <p:cSld>
-    <p:spTree>
-      <p:nvGrpSpPr>
-        <p:cNvPr id="1" name=""/>
-        <p:cNvGrpSpPr/>
-        <p:nvPr/>
-      </p:nvGrpSpPr>
-      <p:grpSpPr/>
-      <p:sp>
-        <p:nvSpPr>
-          <p:cNvPr id="2" name="Title 1"/>
-          <p:cNvSpPr>
-            <a:spLocks noGrp="1"/>
-          </p:cNvSpPr>
-          <p:nvPr>
-            <p:ph type="title"/>
-          </p:nvPr>
-        </p:nvSpPr>
-        <p:spPr/>
-        <p:txBody>
-          <a:bodyPr/>
-          <a:lstStyle/>
-          <a:p>
-            <a:r>
-              <a:t>质量指标走势</a:t>
-            </a:r>
-          </a:p>
-        </p:txBody>
-      </p:sp>
-      <p:sp>
-        <p:nvSpPr>
-          <p:cNvPr id="3" name="Content Placeholder 2"/>
-          <p:cNvSpPr>
-            <a:spLocks noGrp="1"/>
-          </p:cNvSpPr>
-          <p:nvPr>
-            <p:ph idx="1"/>
-          </p:nvPr>
-        </p:nvSpPr>
-        <p:spPr/>
-        <p:txBody>
-          <a:bodyPr/>
-          <a:lstStyle/>
-          <a:p>
-            <a:r>
-              <a:t>第 6 节要点与数据。</a:t>
-            </a:r>
-          </a:p>
-        </p:txBody>
-      </p:sp>
-    </p:spTree>
-  </p:cSld>
-  <p:clrMapOvr>
-    <a:masterClrMapping/>
-  </p:clrMapOvr>
-</p:sld>
-</file>
-
-<file path=ppt/slides/slide7.xml><?xml version="1.0" encoding="utf-8"?>
-<p:sld xmlns:a="http://schemas.openxmlformats.org/drawingml/2006/main" xmlns:p="http://schemas.openxmlformats.org/presentationml/2006/main" xmlns:r="http://schemas.openxmlformats.org/officeDocument/2006/relationships">
-  <p:cSld>
-    <p:spTree>
-      <p:nvGrpSpPr>
-        <p:cNvPr id="1" name=""/>
-        <p:cNvGrpSpPr/>
-        <p:nvPr/>
-      </p:nvGrpSpPr>
-      <p:grpSpPr/>
-      <p:sp>
-        <p:nvSpPr>
-          <p:cNvPr id="2" name="Title 1"/>
-          <p:cNvSpPr>
-            <a:spLocks noGrp="1"/>
-          </p:cNvSpPr>
-          <p:nvPr>
-            <p:ph type="title"/>
-          </p:nvPr>
-        </p:nvSpPr>
-        <p:spPr/>
-        <p:txBody>
-          <a:bodyPr/>
-          <a:lstStyle/>
-          <a:p>
-            <a:r>
-              <a:t>预算风险控制</a:t>
-            </a:r>
-          </a:p>
-        </p:txBody>
-      </p:sp>
-      <p:sp>
-        <p:nvSpPr>
-          <p:cNvPr id="3" name="Content Placeholder 2"/>
-          <p:cNvSpPr>
-            <a:spLocks noGrp="1"/>
-          </p:cNvSpPr>
-          <p:nvPr>
-            <p:ph idx="1"/>
-          </p:nvPr>
-        </p:nvSpPr>
-        <p:spPr/>
-        <p:txBody>
-          <a:bodyPr/>
-          <a:lstStyle/>
-          <a:p>
-            <a:r>
-              <a:t>本节识别当前主要风险并提出缓解措施。</a:t>
-            </a:r>
-          </a:p>
-        </p:txBody>
-      </p:sp>
-    </p:spTree>
-  </p:cSld>
-  <p:clrMapOvr>
-    <a:masterClrMapping/>
-  </p:clrMapOvr>
-</p:sld>
-</file>
-
-<file path=ppt/slides/slide8.xml><?xml version="1.0" encoding="utf-8"?>
-<p:sld xmlns:a="http://schemas.openxmlformats.org/drawingml/2006/main" xmlns:p="http://schemas.openxmlformats.org/presentationml/2006/main" xmlns:r="http://schemas.openxmlformats.org/officeDocument/2006/relationships">
-  <p:cSld>
-    <p:spTree>
-      <p:nvGrpSpPr>
-        <p:cNvPr id="1" name=""/>
-        <p:cNvGrpSpPr/>
-        <p:nvPr/>
-      </p:nvGrpSpPr>
-      <p:grpSpPr/>
-      <p:sp>
-        <p:nvSpPr>
-          <p:cNvPr id="2" name="Title 1"/>
-          <p:cNvSpPr>
-            <a:spLocks noGrp="1"/>
-          </p:cNvSpPr>
-          <p:nvPr>
-            <p:ph type="title"/>
-          </p:nvPr>
-        </p:nvSpPr>
-        <p:spPr/>
-        <p:txBody>
-          <a:bodyPr/>
-          <a:lstStyle/>
-          <a:p>
-            <a:r>
-              <a:t>下一步计划</a:t>
-            </a:r>
-          </a:p>
-        </p:txBody>
-      </p:sp>
-      <p:sp>
-        <p:nvSpPr>
-          <p:cNvPr id="3" name="Content Placeholder 2"/>
-          <p:cNvSpPr>
-            <a:spLocks noGrp="1"/>
-          </p:cNvSpPr>
-          <p:nvPr>
-            <p:ph idx="1"/>
-          </p:nvPr>
-        </p:nvSpPr>
-        <p:spPr/>
-        <p:txBody>
-          <a:bodyPr/>
-          <a:lstStyle/>
-          <a:p>
-            <a:r>
-              <a:t>第 8 节要点与数据。</a:t>
-            </a:r>
-          </a:p>
-        </p:txBody>
-      </p:sp>
-    </p:spTree>
-  </p:cSld>
-  <p:clrMapOvr>
-    <a:masterClrMapping/>
-  </p:clrMapOvr>
-</p:sld>
-</file>
-
-<file path=ppt/slides/slide9.xml><?xml version="1.0" encoding="utf-8"?>
-<p:sld xmlns:a="http://schemas.openxmlformats.org/drawingml/2006/main" xmlns:p="http://schemas.openxmlformats.org/presentationml/2006/main" xmlns:r="http://schemas.openxmlformats.org/officeDocument/2006/relationships">
-  <p:cSld>
-    <p:spTree>
-      <p:nvGrpSpPr>
-        <p:cNvPr id="1" name=""/>
-        <p:cNvGrpSpPr/>
-        <p:nvPr/>
-      </p:nvGrpSpPr>
-      <p:grpSpPr/>
-      <p:sp>
-        <p:nvSpPr>
-          <p:cNvPr id="2" name="Title 1"/>
-          <p:cNvSpPr>
-            <a:spLocks noGrp="1"/>
-          </p:cNvSpPr>
-          <p:nvPr>
-            <p:ph type="title"/>
-          </p:nvPr>
-        </p:nvSpPr>
-        <p:spPr/>
-        <p:txBody>
-          <a:bodyPr/>
-          <a:lstStyle/>
-          <a:p>
-            <a:r>
-              <a:t>附录与数据来源</a:t>
-            </a:r>
-          </a:p>
-        </p:txBody>
-      </p:sp>
-      <p:sp>
-        <p:nvSpPr>
-          <p:cNvPr id="3" name="Content Placeholder 2"/>
-          <p:cNvSpPr>
-            <a:spLocks noGrp="1"/>
-          </p:cNvSpPr>
-          <p:nvPr>
-            <p:ph idx="1"/>
-          </p:nvPr>
-        </p:nvSpPr>
-        <p:spPr/>
-        <p:txBody>
-          <a:bodyPr/>
-          <a:lstStyle/>
-          <a:p>
-            <a:r>
-              <a:t>第 9 节要点与数据。</a:t>
             </a:r>
           </a:p>
         </p:txBody>

</xml_diff>